<commit_message>
Refine wording. Also add simple course description to all the 3 courses
</commit_message>
<xml_diff>
--- a/HCWMPA&S/Slides/1. Prologue.pptx
+++ b/HCWMPA&S/Slides/1. Prologue.pptx
@@ -195,7 +195,7 @@
 <file path=ppt/revisionInfo.xml><?xml version="1.0" encoding="utf-8"?>
 <p1510:revInfo xmlns:a="http://schemas.openxmlformats.org/drawingml/2006/main" xmlns:r="http://schemas.openxmlformats.org/officeDocument/2006/relationships" xmlns:p1510="http://schemas.microsoft.com/office/powerpoint/2015/10/main">
   <p1510:revLst>
-    <p1510:client id="{6A52D03D-2668-4CD0-B99F-8B40710C39C8}" v="41" dt="2026-09-06T00:03:56.231"/>
+    <p1510:client id="{36889B99-D3BA-4E79-9866-CDE2B719A4AE}" v="52" dt="2026-10-31T00:13:25.031"/>
   </p1510:revLst>
 </p1510:revInfo>
 </file>
@@ -205,123 +205,22 @@
   <pc:docChgLst>
     <pc:chgData name="Li, Cong" userId="025630f4-267e-4cb3-8cd5-8795177f99f4" providerId="ADAL" clId="{929A2CC8-B112-421C-81E2-D5D63B23E300}"/>
     <pc:docChg chg="undo custSel addSld delSld modSld">
-      <pc:chgData name="Li, Cong" userId="025630f4-267e-4cb3-8cd5-8795177f99f4" providerId="ADAL" clId="{929A2CC8-B112-421C-81E2-D5D63B23E300}" dt="2026-09-06T00:04:01.428" v="1196" actId="1036"/>
+      <pc:chgData name="Li, Cong" userId="025630f4-267e-4cb3-8cd5-8795177f99f4" providerId="ADAL" clId="{929A2CC8-B112-421C-81E2-D5D63B23E300}" dt="2026-10-31T00:13:25.031" v="1248" actId="20577"/>
       <pc:docMkLst>
         <pc:docMk/>
       </pc:docMkLst>
       <pc:sldChg chg="modSp mod">
-        <pc:chgData name="Li, Cong" userId="025630f4-267e-4cb3-8cd5-8795177f99f4" providerId="ADAL" clId="{929A2CC8-B112-421C-81E2-D5D63B23E300}" dt="2026-08-29T00:43:13.235" v="1167" actId="20577"/>
+        <pc:chgData name="Li, Cong" userId="025630f4-267e-4cb3-8cd5-8795177f99f4" providerId="ADAL" clId="{929A2CC8-B112-421C-81E2-D5D63B23E300}" dt="2026-10-31T00:13:25.031" v="1248" actId="20577"/>
         <pc:sldMkLst>
           <pc:docMk/>
           <pc:sldMk cId="137586777" sldId="402"/>
         </pc:sldMkLst>
         <pc:spChg chg="mod">
-          <ac:chgData name="Li, Cong" userId="025630f4-267e-4cb3-8cd5-8795177f99f4" providerId="ADAL" clId="{929A2CC8-B112-421C-81E2-D5D63B23E300}" dt="2026-08-29T00:43:13.235" v="1167" actId="20577"/>
+          <ac:chgData name="Li, Cong" userId="025630f4-267e-4cb3-8cd5-8795177f99f4" providerId="ADAL" clId="{929A2CC8-B112-421C-81E2-D5D63B23E300}" dt="2026-10-31T00:13:25.031" v="1248" actId="20577"/>
           <ac:spMkLst>
             <pc:docMk/>
             <pc:sldMk cId="137586777" sldId="402"/>
             <ac:spMk id="3" creationId="{9D729D89-C4F5-CB4C-9B8B-073D96BC7894}"/>
-          </ac:spMkLst>
-        </pc:spChg>
-      </pc:sldChg>
-      <pc:sldChg chg="addSp delSp modSp mod addAnim delAnim modAnim">
-        <pc:chgData name="Li, Cong" userId="025630f4-267e-4cb3-8cd5-8795177f99f4" providerId="ADAL" clId="{929A2CC8-B112-421C-81E2-D5D63B23E300}" dt="2026-09-06T00:04:01.428" v="1196" actId="1036"/>
-        <pc:sldMkLst>
-          <pc:docMk/>
-          <pc:sldMk cId="2696307608" sldId="403"/>
-        </pc:sldMkLst>
-        <pc:spChg chg="add mod">
-          <ac:chgData name="Li, Cong" userId="025630f4-267e-4cb3-8cd5-8795177f99f4" providerId="ADAL" clId="{929A2CC8-B112-421C-81E2-D5D63B23E300}" dt="2026-09-06T00:04:01.428" v="1196" actId="1036"/>
-          <ac:spMkLst>
-            <pc:docMk/>
-            <pc:sldMk cId="2696307608" sldId="403"/>
-            <ac:spMk id="6" creationId="{366B08A3-3893-59BF-07AD-88504A0280A2}"/>
-          </ac:spMkLst>
-        </pc:spChg>
-        <pc:spChg chg="add del">
-          <ac:chgData name="Li, Cong" userId="025630f4-267e-4cb3-8cd5-8795177f99f4" providerId="ADAL" clId="{929A2CC8-B112-421C-81E2-D5D63B23E300}" dt="2026-09-06T00:03:14.363" v="1173" actId="478"/>
-          <ac:spMkLst>
-            <pc:docMk/>
-            <pc:sldMk cId="2696307608" sldId="403"/>
-            <ac:spMk id="11" creationId="{DEBDD36B-9DDA-A770-71DB-B4FE942309D0}"/>
-          </ac:spMkLst>
-        </pc:spChg>
-        <pc:spChg chg="del">
-          <ac:chgData name="Li, Cong" userId="025630f4-267e-4cb3-8cd5-8795177f99f4" providerId="ADAL" clId="{929A2CC8-B112-421C-81E2-D5D63B23E300}" dt="2026-09-06T00:03:55.747" v="1187" actId="478"/>
-          <ac:spMkLst>
-            <pc:docMk/>
-            <pc:sldMk cId="2696307608" sldId="403"/>
-            <ac:spMk id="12" creationId="{27E93F12-D99D-0264-2EDB-B2A53CCC8CEF}"/>
-          </ac:spMkLst>
-        </pc:spChg>
-        <pc:picChg chg="add mod">
-          <ac:chgData name="Li, Cong" userId="025630f4-267e-4cb3-8cd5-8795177f99f4" providerId="ADAL" clId="{929A2CC8-B112-421C-81E2-D5D63B23E300}" dt="2026-09-06T00:03:33.892" v="1184" actId="1036"/>
-          <ac:picMkLst>
-            <pc:docMk/>
-            <pc:sldMk cId="2696307608" sldId="403"/>
-            <ac:picMk id="3" creationId="{7CCE549B-4FF0-5913-E562-8F118048B616}"/>
-          </ac:picMkLst>
-        </pc:picChg>
-        <pc:picChg chg="add mod">
-          <ac:chgData name="Li, Cong" userId="025630f4-267e-4cb3-8cd5-8795177f99f4" providerId="ADAL" clId="{929A2CC8-B112-421C-81E2-D5D63B23E300}" dt="2026-09-06T00:03:33.892" v="1184" actId="1036"/>
-          <ac:picMkLst>
-            <pc:docMk/>
-            <pc:sldMk cId="2696307608" sldId="403"/>
-            <ac:picMk id="4" creationId="{83DB7D96-49D2-04A8-7319-93DB2F0238DE}"/>
-          </ac:picMkLst>
-        </pc:picChg>
-        <pc:picChg chg="del">
-          <ac:chgData name="Li, Cong" userId="025630f4-267e-4cb3-8cd5-8795177f99f4" providerId="ADAL" clId="{929A2CC8-B112-421C-81E2-D5D63B23E300}" dt="2026-09-06T00:03:12.657" v="1171" actId="478"/>
-          <ac:picMkLst>
-            <pc:docMk/>
-            <pc:sldMk cId="2696307608" sldId="403"/>
-            <ac:picMk id="7" creationId="{7FFCF86B-8068-A91B-3A0E-C7A3A0B3CA33}"/>
-          </ac:picMkLst>
-        </pc:picChg>
-        <pc:picChg chg="del">
-          <ac:chgData name="Li, Cong" userId="025630f4-267e-4cb3-8cd5-8795177f99f4" providerId="ADAL" clId="{929A2CC8-B112-421C-81E2-D5D63B23E300}" dt="2026-09-06T00:03:15.564" v="1174" actId="478"/>
-          <ac:picMkLst>
-            <pc:docMk/>
-            <pc:sldMk cId="2696307608" sldId="403"/>
-            <ac:picMk id="9" creationId="{92964AE3-B9B1-CF76-6C5F-53A02098EF93}"/>
-          </ac:picMkLst>
-        </pc:picChg>
-      </pc:sldChg>
-      <pc:sldChg chg="modSp add mod modAnim">
-        <pc:chgData name="Li, Cong" userId="025630f4-267e-4cb3-8cd5-8795177f99f4" providerId="ADAL" clId="{929A2CC8-B112-421C-81E2-D5D63B23E300}" dt="2026-08-15T00:31:58.860" v="1131" actId="20577"/>
-        <pc:sldMkLst>
-          <pc:docMk/>
-          <pc:sldMk cId="278756743" sldId="411"/>
-        </pc:sldMkLst>
-        <pc:spChg chg="mod">
-          <ac:chgData name="Li, Cong" userId="025630f4-267e-4cb3-8cd5-8795177f99f4" providerId="ADAL" clId="{929A2CC8-B112-421C-81E2-D5D63B23E300}" dt="2026-08-14T22:26:43.697" v="748" actId="20577"/>
-          <ac:spMkLst>
-            <pc:docMk/>
-            <pc:sldMk cId="278756743" sldId="411"/>
-            <ac:spMk id="2" creationId="{BAE1F180-8F71-395B-63AB-5084F6E35C26}"/>
-          </ac:spMkLst>
-        </pc:spChg>
-        <pc:spChg chg="mod">
-          <ac:chgData name="Li, Cong" userId="025630f4-267e-4cb3-8cd5-8795177f99f4" providerId="ADAL" clId="{929A2CC8-B112-421C-81E2-D5D63B23E300}" dt="2026-08-15T00:31:58.860" v="1131" actId="20577"/>
-          <ac:spMkLst>
-            <pc:docMk/>
-            <pc:sldMk cId="278756743" sldId="411"/>
-            <ac:spMk id="3" creationId="{5AF7FEE1-42B2-1BBF-FA2E-EE9B74953B0A}"/>
-          </ac:spMkLst>
-        </pc:spChg>
-      </pc:sldChg>
-      <pc:sldChg chg="modSp add del">
-        <pc:chgData name="Li, Cong" userId="025630f4-267e-4cb3-8cd5-8795177f99f4" providerId="ADAL" clId="{929A2CC8-B112-421C-81E2-D5D63B23E300}" dt="2026-09-05T02:06:53.764" v="1170"/>
-        <pc:sldMkLst>
-          <pc:docMk/>
-          <pc:sldMk cId="4146604278" sldId="412"/>
-        </pc:sldMkLst>
-        <pc:spChg chg="mod">
-          <ac:chgData name="Li, Cong" userId="025630f4-267e-4cb3-8cd5-8795177f99f4" providerId="ADAL" clId="{929A2CC8-B112-421C-81E2-D5D63B23E300}" dt="2026-09-05T02:06:47.286" v="1169"/>
-          <ac:spMkLst>
-            <pc:docMk/>
-            <pc:sldMk cId="4146604278" sldId="412"/>
-            <ac:spMk id="5" creationId="{6463F9D5-871A-17AA-D707-AD92A82F3F7C}"/>
           </ac:spMkLst>
         </pc:spChg>
       </pc:sldChg>
@@ -6961,38 +6860,30 @@
             <a:pPr lvl="1"/>
             <a:r>
               <a:rPr lang="en-US" altLang="zh-CN" dirty="0"/>
-              <a:t>Still having limitations in coding </a:t>
-            </a:r>
-            <a:r>
-              <a:rPr lang="en-US" altLang="zh-CN"/>
-              <a:t>today  </a:t>
-            </a:r>
-            <a:br>
-              <a:rPr lang="en-US" altLang="zh-CN"/>
-            </a:br>
-            <a:r>
-              <a:rPr lang="zh-CN" altLang="en-US"/>
-              <a:t>目</a:t>
-            </a:r>
-            <a:r>
-              <a:rPr lang="zh-CN" altLang="en-US" dirty="0"/>
-              <a:t>前在编程中仍有局限</a:t>
-            </a:r>
-            <a:r>
-              <a:rPr lang="en-US" altLang="zh-CN" dirty="0"/>
-              <a:t>  </a:t>
-            </a:r>
-          </a:p>
-          <a:p>
-            <a:r>
-              <a:rPr lang="en-US" altLang="zh-CN" dirty="0"/>
-              <a:t>Right Knowledge Required  </a:t>
+              <a:t>Still having limitations in coding today  </a:t>
             </a:r>
             <a:br>
               <a:rPr lang="en-US" altLang="zh-CN" dirty="0"/>
             </a:br>
             <a:r>
               <a:rPr lang="zh-CN" altLang="en-US" dirty="0"/>
+              <a:t>目前在编程中仍有局限</a:t>
+            </a:r>
+            <a:r>
+              <a:rPr lang="en-US" altLang="zh-CN" dirty="0"/>
+              <a:t>  </a:t>
+            </a:r>
+          </a:p>
+          <a:p>
+            <a:r>
+              <a:rPr lang="en-US" altLang="zh-CN" dirty="0"/>
+              <a:t>Right Knowledge Required  </a:t>
+            </a:r>
+            <a:br>
+              <a:rPr lang="en-US" altLang="zh-CN" dirty="0"/>
+            </a:br>
+            <a:r>
+              <a:rPr lang="zh-CN" altLang="en-US" dirty="0"/>
               <a:t>需要合适的知识</a:t>
             </a:r>
             <a:r>
@@ -7004,11 +6895,11 @@
             <a:pPr lvl="1"/>
             <a:r>
               <a:rPr lang="en-US" altLang="zh-CN" dirty="0"/>
-              <a:t>Create new ideas  </a:t>
-            </a:r>
-            <a:r>
-              <a:rPr lang="zh-CN" altLang="en-US" dirty="0"/>
-              <a:t>产生新想法</a:t>
+              <a:t>Ask right question  </a:t>
+            </a:r>
+            <a:r>
+              <a:rPr lang="zh-CN" altLang="en-US"/>
+              <a:t>提出正确的问题</a:t>
             </a:r>
             <a:endParaRPr lang="en-US" altLang="zh-CN" dirty="0"/>
           </a:p>

</xml_diff>